<commit_message>
feat: implement 11 missing checklist items in EN/JA manuscripts
- Add Table 1 (4 pairwise outliers with z-scores, permutation p-values)
- Add Table 2 (ABO sub-lineage composition by region, 6 regions)
- Add outlier text: KHV-PEL z=2.14, CHS-PEL z=2.06, CDX-PEL z=2.01, CLM-Pathan z=2.01
- Add Lydekker Line reference to Wallace section
- Add partial correlation r=-0.19, p < 10^-18
- Add bootstrap CI [-2.74, -2.33] x 10^-5/km (10,000 resamples)
- Add sensitivity analysis Figure 4 (admixed exclusion, r: -0.49 -> -0.62)
- Expand testable predictions from 4 to 6 (add Austronesian + O2 density-dependent)
- Add 4th Quilodran differentiation point (hypothesis-generating)
- Renumber all figures sequentially (1-9 with Fig 4 = sensitivity)
- Regenerate EN/JA docx, submission zips with all updates

Co-Authored-By: Tatsuki Onishi <bougtoir@gmail.com>
</commit_message>
<xml_diff>
--- a/denisovan-archaic-dna-analysis/docs/figures_en.pptx
+++ b/denisovan-archaic-dna-analysis/docs/figures_en.pptx
@@ -3142,8 +3142,8 @@
         </p:blipFill>
         <p:spPr>
           <a:xfrm>
-            <a:off x="715957" y="822960"/>
-            <a:ext cx="10759781" cy="5029200"/>
+            <a:off x="665951" y="822960"/>
+            <a:ext cx="10859793" cy="5029200"/>
           </a:xfrm>
           <a:prstGeom prst="rect">
             <a:avLst/>

</xml_diff>

<commit_message>
feat: replace Minard figure with PR#186 polygon-based version
- Polygon-based flow bands (width proportional to effective population size)
- ABO sub-lineage compositions annotated at branch points
- Wallace Line, 3 Denisovan admixture events, time axis
- Sub-lineage paradox highlighted (E.Asia 100% Chag vs Americas 52/24/24)
- O2 paradox annotation (Solomon Is. 5-16% vs E.Asia <0.01%)
- Updated EN/JA captions to match new figure content
- Regenerated docx and submission zips

Co-Authored-By: Tatsuki Onishi <bougtoir@gmail.com>
</commit_message>
<xml_diff>
--- a/denisovan-archaic-dna-analysis/docs/figures_en.pptx
+++ b/denisovan-archaic-dna-analysis/docs/figures_en.pptx
@@ -3366,8 +3366,8 @@
         </p:blipFill>
         <p:spPr>
           <a:xfrm>
-            <a:off x="1910771" y="822960"/>
-            <a:ext cx="8370152" cy="5029200"/>
+            <a:off x="1503718" y="822960"/>
+            <a:ext cx="9184258" cy="5029200"/>
           </a:xfrm>
           <a:prstGeom prst="rect">
             <a:avLst/>

</xml_diff>

<commit_message>
feat: replace Fig 9 world map with Pacific-centered projection
- Change Robinson projection center from 0° to 180° longitude
- Bering Strait now at map center, matching the paper's focus on
  East Asia-Americas migration connections
- Add Peruvian (PEL) and Karitiana/Surui populations (key outlier pairs)
- Regenerate docx, pptx, submission zip

Co-Authored-By: Tatsuki Onishi <bougtoir@gmail.com>
</commit_message>
<xml_diff>
--- a/denisovan-archaic-dna-analysis/docs/figures_en.pptx
+++ b/denisovan-archaic-dna-analysis/docs/figures_en.pptx
@@ -3142,8 +3142,8 @@
         </p:blipFill>
         <p:spPr>
           <a:xfrm>
-            <a:off x="665951" y="822960"/>
-            <a:ext cx="10859793" cy="5029200"/>
+            <a:off x="715957" y="822960"/>
+            <a:ext cx="10759781" cy="5029200"/>
           </a:xfrm>
           <a:prstGeom prst="rect">
             <a:avLst/>
@@ -3366,8 +3366,8 @@
         </p:blipFill>
         <p:spPr>
           <a:xfrm>
-            <a:off x="1503718" y="822960"/>
-            <a:ext cx="9184258" cy="5029200"/>
+            <a:off x="1910771" y="822960"/>
+            <a:ext cx="8370152" cy="5029200"/>
           </a:xfrm>
           <a:prstGeom prst="rect">
             <a:avLst/>

</xml_diff>

<commit_message>
fix: regenerate docx with correct polygon-based Minard figure (Fig 3)
- Regenerate manuscript_bioessays_en.docx to ensure polygon-based Minard
  figure is correctly embedded inline
- Regenerate pptx and submission zip

Co-Authored-By: Tatsuki Onishi <bougtoir@gmail.com>
</commit_message>
<xml_diff>
--- a/denisovan-archaic-dna-analysis/docs/figures_en.pptx
+++ b/denisovan-archaic-dna-analysis/docs/figures_en.pptx
@@ -3366,8 +3366,8 @@
         </p:blipFill>
         <p:spPr>
           <a:xfrm>
-            <a:off x="1910771" y="822960"/>
-            <a:ext cx="8370152" cy="5029200"/>
+            <a:off x="1503718" y="822960"/>
+            <a:ext cx="9184258" cy="5029200"/>
           </a:xfrm>
           <a:prstGeom prst="rect">
             <a:avLst/>

</xml_diff>